<commit_message>
seminar: release 덱에 A3b 레이더 삽입 (28->29장, XML 수술)
사용자 요청("ppt 그 부분 추가해봐") - 팔각형 레이더를 부록으로 복원.
- slide24(A3 히트맵) 복제 -> A3b "Candidate profiles across eight axes
  (radar)", cascade_radar_6panel.png 임베드, source 라인 교체
- 뒷장 인쇄 페이지번호 4장 +1 재조정 (25-28 -> 26-29)
- 이 pptx 는 sldId 마다 xmlns:r 을 inline 선언하는 구조라 삽입 항목에
  선언을 붙여 해결. validate --original PASSED, 삽입 장 렌더 육안 확인
- 본문 21장 흐름·시간은 불변 (부록이라 발표 시간 영향 0)
- 대본 v2: A3b 운용법 추가, 부록 번호 29장 체계로 갱신, pair 레이더는
  덱 밖 예비로 유지

Co-Authored-By: Claude Opus 5 <noreply@anthropic.com>
Claude-Session: https://claude.ai/code/session_01L44TWYrHkcm4PH5ihWSSCw
</commit_message>
<xml_diff>
--- a/kb/seminars/Research_Seminar_2026_08_cascade_release.pptx
+++ b/kb/seminars/Research_Seminar_2026_08_cascade_release.pptx
@@ -32,6 +32,7 @@
     <p:sldId xmlns:r="http://schemas.openxmlformats.org/officeDocument/2006/relationships" id="277" r:id="R560efd5f214a4f53"/>
     <p:sldId xmlns:r="http://schemas.openxmlformats.org/officeDocument/2006/relationships" id="278" r:id="Rda12e9a0236f40d1"/>
     <p:sldId xmlns:r="http://schemas.openxmlformats.org/officeDocument/2006/relationships" id="279" r:id="R4a1f9f841ded40d5"/>
+    <p:sldId xmlns:r="http://schemas.openxmlformats.org/officeDocument/2006/relationships" id="284" r:id="rId1"/>
     <p:sldId xmlns:r="http://schemas.openxmlformats.org/officeDocument/2006/relationships" id="280" r:id="R314fce711b224575"/>
     <p:sldId xmlns:r="http://schemas.openxmlformats.org/officeDocument/2006/relationships" id="281" r:id="Recc2ae3b823a4b93"/>
     <p:sldId xmlns:r="http://schemas.openxmlformats.org/officeDocument/2006/relationships" id="282" r:id="R1e7194ef8160481a"/>
@@ -21094,7 +21095,7 @@
                 <a:ea typeface="Arial"/>
                 <a:cs typeface="Arial"/>
               </a:rPr>
-              <a:t>25</a:t>
+              <a:t>26</a:t>
             </a:r>
             <a:endParaRPr sz="900"/>
           </a:p>
@@ -22206,7 +22207,7 @@
                 <a:ea typeface="Arial"/>
                 <a:cs typeface="Arial"/>
               </a:rPr>
-              <a:t>26</a:t>
+              <a:t>27</a:t>
             </a:r>
             <a:endParaRPr sz="900"/>
           </a:p>
@@ -23305,7 +23306,7 @@
                 <a:ea typeface="Arial"/>
                 <a:cs typeface="Arial"/>
               </a:rPr>
-              <a:t>27</a:t>
+              <a:t>28</a:t>
             </a:r>
             <a:endParaRPr sz="900"/>
           </a:p>
@@ -24771,7 +24772,7 @@
                 <a:ea typeface="Arial"/>
                 <a:cs typeface="Arial"/>
               </a:rPr>
-              <a:t>28</a:t>
+              <a:t>29</a:t>
             </a:r>
             <a:endParaRPr sz="900"/>
           </a:p>
@@ -26042,6 +26043,431 @@
     <p:extLst>
       <p:ext uri="{BB962C8B-B14F-4D97-AF65-F5344CB8AC3E}">
         <p14:creationId xmlns:p14="http://schemas.microsoft.com/office/powerpoint/2010/main" val="777649955"/>
+      </p:ext>
+    </p:extLst>
+  </p:cSld>
+</p:sld>
+</file>
+
+<file path=ppt/slides/slide29.xml><?xml version="1.0" encoding="utf-8"?>
+<p:sld xmlns:p="http://schemas.openxmlformats.org/presentationml/2006/main">
+  <p:cSld>
+    <p:spTree>
+      <p:nvGrpSpPr>
+        <p:cNvPr id="1" name=""/>
+        <p:cNvGrpSpPr/>
+        <p:nvPr/>
+      </p:nvGrpSpPr>
+      <p:grpSpPr>
+        <a:xfrm xmlns:a="http://schemas.openxmlformats.org/drawingml/2006/main"/>
+      </p:grpSpPr>
+      <p:sp>
+        <p:nvSpPr>
+          <p:cNvPr id="2" name="Text 0">
+            <a:extLst xmlns:a="http://schemas.openxmlformats.org/drawingml/2006/main">
+              <a:ext uri="{FF2B5EF4-FFF2-40B4-BE49-F238E27FC236}">
+                <a16:creationId xmlns:a16="http://schemas.microsoft.com/office/drawing/2014/main" id="{CF7310F9-2557-4085-9137-F5E593536A0D}"/>
+              </a:ext>
+            </a:extLst>
+          </p:cNvPr>
+          <p:cNvSpPr>
+            <a:spLocks xmlns:a="http://schemas.openxmlformats.org/drawingml/2006/main" noGrp="1"/>
+          </p:cNvSpPr>
+          <p:nvPr/>
+        </p:nvSpPr>
+        <p:spPr>
+          <a:xfrm xmlns:a="http://schemas.openxmlformats.org/drawingml/2006/main">
+            <a:off x="548640" y="256032"/>
+            <a:ext cx="5029200" cy="548640"/>
+          </a:xfrm>
+          <a:prstGeom xmlns:a="http://schemas.openxmlformats.org/drawingml/2006/main" prst="rect">
+            <a:avLst/>
+          </a:prstGeom>
+          <a:noFill xmlns:a="http://schemas.openxmlformats.org/drawingml/2006/main"/>
+        </p:spPr>
+        <p:txBody>
+          <a:bodyPr xmlns:a="http://schemas.openxmlformats.org/drawingml/2006/main" wrap="square" lIns="0" tIns="0" rIns="0" bIns="0" anchor="ctr"/>
+          <a:lstStyle xmlns:a="http://schemas.openxmlformats.org/drawingml/2006/main"/>
+          <a:p xmlns:a="http://schemas.openxmlformats.org/drawingml/2006/main">
+            <a:pPr marL="0" indent="0">
+              <a:buNone/>
+            </a:pPr>
+            <a:r>
+              <a:rPr sz="2600" b="1">
+                <a:solidFill>
+                  <a:srgbClr val="1F4E79"/>
+                </a:solidFill>
+                <a:latin typeface="Arial"/>
+                <a:ea typeface="Arial"/>
+                <a:cs typeface="Arial"/>
+              </a:rPr>
+              <a:t>Appendix A3b</a:t>
+            </a:r>
+            <a:endParaRPr sz="2800"/>
+          </a:p>
+        </p:txBody>
+      </p:sp>
+      <p:sp>
+        <p:nvSpPr>
+          <p:cNvPr id="3" name="Shape 1">
+            <a:extLst xmlns:a="http://schemas.openxmlformats.org/drawingml/2006/main">
+              <a:ext uri="{FF2B5EF4-FFF2-40B4-BE49-F238E27FC236}">
+                <a16:creationId xmlns:a16="http://schemas.microsoft.com/office/drawing/2014/main" id="{ACD3D80D-AF57-4C7D-80D5-73F8BE8A6B7C}"/>
+              </a:ext>
+            </a:extLst>
+          </p:cNvPr>
+          <p:cNvSpPr>
+            <a:spLocks xmlns:a="http://schemas.openxmlformats.org/drawingml/2006/main" noGrp="1"/>
+          </p:cNvSpPr>
+          <p:nvPr/>
+        </p:nvSpPr>
+        <p:spPr>
+          <a:xfrm xmlns:a="http://schemas.openxmlformats.org/drawingml/2006/main">
+            <a:off x="548640" y="868680"/>
+            <a:ext cx="8046720" cy="0"/>
+          </a:xfrm>
+          <a:prstGeom xmlns:a="http://schemas.openxmlformats.org/drawingml/2006/main" prst="line">
+            <a:avLst/>
+          </a:prstGeom>
+          <a:noFill xmlns:a="http://schemas.openxmlformats.org/drawingml/2006/main"/>
+          <a:ln xmlns:a="http://schemas.openxmlformats.org/drawingml/2006/main" w="12700">
+            <a:solidFill>
+              <a:srgbClr val="BFBFBF"/>
+            </a:solidFill>
+            <a:prstDash val="solid"/>
+          </a:ln>
+        </p:spPr>
+      </p:sp>
+      <p:sp>
+        <p:nvSpPr>
+          <p:cNvPr id="4" name="Shape 2">
+            <a:extLst xmlns:a="http://schemas.openxmlformats.org/drawingml/2006/main">
+              <a:ext uri="{FF2B5EF4-FFF2-40B4-BE49-F238E27FC236}">
+                <a16:creationId xmlns:a16="http://schemas.microsoft.com/office/drawing/2014/main" id="{CEB16169-8BED-48B7-8A7C-DE82B927A69A}"/>
+              </a:ext>
+            </a:extLst>
+          </p:cNvPr>
+          <p:cNvSpPr>
+            <a:spLocks xmlns:a="http://schemas.openxmlformats.org/drawingml/2006/main" noGrp="1"/>
+          </p:cNvSpPr>
+          <p:nvPr/>
+        </p:nvSpPr>
+        <p:spPr>
+          <a:xfrm xmlns:a="http://schemas.openxmlformats.org/drawingml/2006/main">
+            <a:off x="566928" y="1033272"/>
+            <a:ext cx="109728" cy="109728"/>
+          </a:xfrm>
+          <a:prstGeom xmlns:a="http://schemas.openxmlformats.org/drawingml/2006/main" prst="rect">
+            <a:avLst/>
+          </a:prstGeom>
+          <a:solidFill xmlns:a="http://schemas.openxmlformats.org/drawingml/2006/main">
+            <a:srgbClr val="9E2A2B"/>
+          </a:solidFill>
+        </p:spPr>
+      </p:sp>
+      <p:sp>
+        <p:nvSpPr>
+          <p:cNvPr id="5" name="Text 3">
+            <a:extLst xmlns:a="http://schemas.openxmlformats.org/drawingml/2006/main">
+              <a:ext uri="{FF2B5EF4-FFF2-40B4-BE49-F238E27FC236}">
+                <a16:creationId xmlns:a16="http://schemas.microsoft.com/office/drawing/2014/main" id="{A9A43A32-4C7C-4062-8CD6-A90E2F33C134}"/>
+              </a:ext>
+            </a:extLst>
+          </p:cNvPr>
+          <p:cNvSpPr>
+            <a:spLocks xmlns:a="http://schemas.openxmlformats.org/drawingml/2006/main" noGrp="1"/>
+          </p:cNvSpPr>
+          <p:nvPr/>
+        </p:nvSpPr>
+        <p:spPr>
+          <a:xfrm xmlns:a="http://schemas.openxmlformats.org/drawingml/2006/main">
+            <a:off x="804672" y="932688"/>
+            <a:ext cx="7772400" cy="320040"/>
+          </a:xfrm>
+          <a:prstGeom xmlns:a="http://schemas.openxmlformats.org/drawingml/2006/main" prst="rect">
+            <a:avLst/>
+          </a:prstGeom>
+          <a:noFill xmlns:a="http://schemas.openxmlformats.org/drawingml/2006/main"/>
+        </p:spPr>
+        <p:txBody>
+          <a:bodyPr xmlns:a="http://schemas.openxmlformats.org/drawingml/2006/main" wrap="square" lIns="0" tIns="0" rIns="0" bIns="0" anchor="ctr"/>
+          <a:lstStyle xmlns:a="http://schemas.openxmlformats.org/drawingml/2006/main"/>
+          <a:p xmlns:a="http://schemas.openxmlformats.org/drawingml/2006/main">
+            <a:pPr marL="0" indent="0">
+              <a:buNone/>
+            </a:pPr>
+            <a:r>
+              <a:rPr sz="1400" b="1">
+                <a:solidFill>
+                  <a:srgbClr val="262626"/>
+                </a:solidFill>
+                <a:latin typeface="Arial"/>
+                <a:ea typeface="Arial"/>
+                <a:cs typeface="Arial"/>
+              </a:rPr>
+              <a:t>Candidate profiles across eight axes (radar)</a:t>
+            </a:r>
+            <a:endParaRPr sz="1400"/>
+          </a:p>
+        </p:txBody>
+      </p:sp>
+      <p:sp>
+        <p:nvSpPr>
+          <p:cNvPr id="6" name="Text 4">
+            <a:extLst xmlns:a="http://schemas.openxmlformats.org/drawingml/2006/main">
+              <a:ext uri="{FF2B5EF4-FFF2-40B4-BE49-F238E27FC236}">
+                <a16:creationId xmlns:a16="http://schemas.microsoft.com/office/drawing/2014/main" id="{4F019564-0DE4-4F35-A484-C647036276F6}"/>
+              </a:ext>
+            </a:extLst>
+          </p:cNvPr>
+          <p:cNvSpPr>
+            <a:spLocks xmlns:a="http://schemas.openxmlformats.org/drawingml/2006/main" noGrp="1"/>
+          </p:cNvSpPr>
+          <p:nvPr/>
+        </p:nvSpPr>
+        <p:spPr>
+          <a:xfrm xmlns:a="http://schemas.openxmlformats.org/drawingml/2006/main">
+            <a:off x="548640" y="6446520"/>
+            <a:ext cx="2377440" cy="274320"/>
+          </a:xfrm>
+          <a:prstGeom xmlns:a="http://schemas.openxmlformats.org/drawingml/2006/main" prst="rect">
+            <a:avLst/>
+          </a:prstGeom>
+          <a:noFill xmlns:a="http://schemas.openxmlformats.org/drawingml/2006/main"/>
+        </p:spPr>
+        <p:txBody>
+          <a:bodyPr xmlns:a="http://schemas.openxmlformats.org/drawingml/2006/main" wrap="square" lIns="0" tIns="0" rIns="0" bIns="0" anchor="ctr"/>
+          <a:lstStyle xmlns:a="http://schemas.openxmlformats.org/drawingml/2006/main"/>
+          <a:p xmlns:a="http://schemas.openxmlformats.org/drawingml/2006/main">
+            <a:pPr marL="0" indent="0">
+              <a:buNone/>
+            </a:pPr>
+            <a:r>
+              <a:rPr sz="850" b="1">
+                <a:solidFill>
+                  <a:srgbClr val="1F4E79"/>
+                </a:solidFill>
+                <a:latin typeface="Arial"/>
+                <a:ea typeface="Arial"/>
+                <a:cs typeface="Arial"/>
+              </a:rPr>
+              <a:t>HANYANG UNIVERSITY</a:t>
+            </a:r>
+            <a:endParaRPr sz="850"/>
+          </a:p>
+        </p:txBody>
+      </p:sp>
+      <p:sp>
+        <p:nvSpPr>
+          <p:cNvPr id="7" name="Text 5">
+            <a:extLst xmlns:a="http://schemas.openxmlformats.org/drawingml/2006/main">
+              <a:ext uri="{FF2B5EF4-FFF2-40B4-BE49-F238E27FC236}">
+                <a16:creationId xmlns:a16="http://schemas.microsoft.com/office/drawing/2014/main" id="{A138EC1B-5A2B-49CE-8F25-93213B37570C}"/>
+              </a:ext>
+            </a:extLst>
+          </p:cNvPr>
+          <p:cNvSpPr>
+            <a:spLocks xmlns:a="http://schemas.openxmlformats.org/drawingml/2006/main" noGrp="1"/>
+          </p:cNvSpPr>
+          <p:nvPr/>
+        </p:nvSpPr>
+        <p:spPr>
+          <a:xfrm xmlns:a="http://schemas.openxmlformats.org/drawingml/2006/main">
+            <a:off x="3291840" y="6446520"/>
+            <a:ext cx="2560320" cy="274320"/>
+          </a:xfrm>
+          <a:prstGeom xmlns:a="http://schemas.openxmlformats.org/drawingml/2006/main" prst="rect">
+            <a:avLst/>
+          </a:prstGeom>
+          <a:noFill xmlns:a="http://schemas.openxmlformats.org/drawingml/2006/main"/>
+        </p:spPr>
+        <p:txBody>
+          <a:bodyPr xmlns:a="http://schemas.openxmlformats.org/drawingml/2006/main" wrap="square" lIns="0" tIns="0" rIns="0" bIns="0" anchor="ctr"/>
+          <a:lstStyle xmlns:a="http://schemas.openxmlformats.org/drawingml/2006/main"/>
+          <a:p xmlns:a="http://schemas.openxmlformats.org/drawingml/2006/main">
+            <a:pPr marL="0" indent="0" algn="ctr">
+              <a:buNone/>
+            </a:pPr>
+            <a:r>
+              <a:rPr sz="850">
+                <a:solidFill>
+                  <a:srgbClr val="7F7F7F"/>
+                </a:solidFill>
+                <a:latin typeface="Arial"/>
+                <a:ea typeface="Arial"/>
+                <a:cs typeface="Arial"/>
+              </a:rPr>
+              <a:t>Battery Materials Lab.</a:t>
+            </a:r>
+            <a:endParaRPr sz="850"/>
+          </a:p>
+        </p:txBody>
+      </p:sp>
+      <p:sp>
+        <p:nvSpPr>
+          <p:cNvPr id="8" name="Text 6">
+            <a:extLst xmlns:a="http://schemas.openxmlformats.org/drawingml/2006/main">
+              <a:ext uri="{FF2B5EF4-FFF2-40B4-BE49-F238E27FC236}">
+                <a16:creationId xmlns:a16="http://schemas.microsoft.com/office/drawing/2014/main" id="{391BC42A-CC55-4FBF-AFCD-69B730A3DBF6}"/>
+              </a:ext>
+            </a:extLst>
+          </p:cNvPr>
+          <p:cNvSpPr>
+            <a:spLocks xmlns:a="http://schemas.openxmlformats.org/drawingml/2006/main" noGrp="1"/>
+          </p:cNvSpPr>
+          <p:nvPr/>
+        </p:nvSpPr>
+        <p:spPr>
+          <a:xfrm xmlns:a="http://schemas.openxmlformats.org/drawingml/2006/main">
+            <a:off x="8366760" y="6446520"/>
+            <a:ext cx="365760" cy="274320"/>
+          </a:xfrm>
+          <a:prstGeom xmlns:a="http://schemas.openxmlformats.org/drawingml/2006/main" prst="rect">
+            <a:avLst/>
+          </a:prstGeom>
+          <a:noFill xmlns:a="http://schemas.openxmlformats.org/drawingml/2006/main"/>
+        </p:spPr>
+        <p:txBody>
+          <a:bodyPr xmlns:a="http://schemas.openxmlformats.org/drawingml/2006/main" wrap="square" lIns="0" tIns="0" rIns="0" bIns="0" anchor="ctr"/>
+          <a:lstStyle xmlns:a="http://schemas.openxmlformats.org/drawingml/2006/main"/>
+          <a:p xmlns:a="http://schemas.openxmlformats.org/drawingml/2006/main">
+            <a:pPr marL="0" indent="0" algn="r">
+              <a:buNone/>
+            </a:pPr>
+            <a:r>
+              <a:rPr sz="900">
+                <a:solidFill>
+                  <a:srgbClr val="7F7F7F"/>
+                </a:solidFill>
+                <a:latin typeface="Arial"/>
+                <a:ea typeface="Arial"/>
+                <a:cs typeface="Arial"/>
+              </a:rPr>
+              <a:t>25</a:t>
+            </a:r>
+            <a:endParaRPr sz="900"/>
+          </a:p>
+        </p:txBody>
+      </p:sp>
+      <p:pic>
+        <p:nvPicPr>
+          <p:cNvPr id="21" name="Image 0"/>
+          <p:cNvPicPr>
+            <a:picLocks xmlns:a="http://schemas.openxmlformats.org/drawingml/2006/main" noChangeAspect="1"/>
+          </p:cNvPicPr>
+          <p:nvPr/>
+        </p:nvPicPr>
+        <p:blipFill>
+          <a:blip xmlns:r="http://schemas.openxmlformats.org/officeDocument/2006/relationships" xmlns:a="http://schemas.openxmlformats.org/drawingml/2006/main" r:embed="R2e135c6e07ff45c0"/>
+          <a:srcRect xmlns:a="http://schemas.openxmlformats.org/drawingml/2006/main" l="0" t="0" r="0" b="0"/>
+          <a:stretch xmlns:a="http://schemas.openxmlformats.org/drawingml/2006/main"/>
+        </p:blipFill>
+        <p:spPr>
+          <a:xfrm xmlns:a="http://schemas.openxmlformats.org/drawingml/2006/main">
+            <a:off x="731520" y="1325880"/>
+            <a:ext cx="7680960" cy="4572000"/>
+          </a:xfrm>
+          <a:prstGeom xmlns:a="http://schemas.openxmlformats.org/drawingml/2006/main" prst="rect">
+            <a:avLst/>
+          </a:prstGeom>
+        </p:spPr>
+      </p:pic>
+      <p:sp>
+        <p:nvSpPr>
+          <p:cNvPr id="11" name="Text 7">
+            <a:extLst xmlns:a="http://schemas.openxmlformats.org/drawingml/2006/main">
+              <a:ext uri="{FF2B5EF4-FFF2-40B4-BE49-F238E27FC236}">
+                <a16:creationId xmlns:a16="http://schemas.microsoft.com/office/drawing/2014/main" id="{354B51B8-83F5-490A-8A7D-29C5F7D52620}"/>
+              </a:ext>
+            </a:extLst>
+          </p:cNvPr>
+          <p:cNvSpPr>
+            <a:spLocks xmlns:a="http://schemas.openxmlformats.org/drawingml/2006/main" noGrp="1"/>
+          </p:cNvSpPr>
+          <p:nvPr/>
+        </p:nvSpPr>
+        <p:spPr>
+          <a:xfrm xmlns:a="http://schemas.openxmlformats.org/drawingml/2006/main">
+            <a:off x="731520" y="5925312"/>
+            <a:ext cx="7680960" cy="256032"/>
+          </a:xfrm>
+          <a:prstGeom xmlns:a="http://schemas.openxmlformats.org/drawingml/2006/main" prst="rect">
+            <a:avLst/>
+          </a:prstGeom>
+          <a:noFill xmlns:a="http://schemas.openxmlformats.org/drawingml/2006/main"/>
+        </p:spPr>
+        <p:txBody>
+          <a:bodyPr xmlns:a="http://schemas.openxmlformats.org/drawingml/2006/main" wrap="square" lIns="0" tIns="0" rIns="0" bIns="0" anchor="ctr"/>
+          <a:lstStyle xmlns:a="http://schemas.openxmlformats.org/drawingml/2006/main"/>
+          <a:p xmlns:a="http://schemas.openxmlformats.org/drawingml/2006/main">
+            <a:pPr marL="0" indent="0" algn="ctr">
+              <a:buNone/>
+            </a:pPr>
+            <a:r>
+              <a:rPr sz="938" i="1">
+                <a:solidFill>
+                  <a:srgbClr val="7F7F7F"/>
+                </a:solidFill>
+                <a:latin typeface="Arial"/>
+                <a:ea typeface="Arial"/>
+                <a:cs typeface="Arial"/>
+              </a:rPr>
+              <a:t>Within-pool favorable percentiles + first-stop gate — no universal composite score, no winner</a:t>
+            </a:r>
+            <a:endParaRPr sz="850"/>
+          </a:p>
+        </p:txBody>
+      </p:sp>
+      <p:sp>
+        <p:nvSpPr>
+          <p:cNvPr id="12" name="Text 8">
+            <a:extLst xmlns:a="http://schemas.openxmlformats.org/drawingml/2006/main">
+              <a:ext uri="{FF2B5EF4-FFF2-40B4-BE49-F238E27FC236}">
+                <a16:creationId xmlns:a16="http://schemas.microsoft.com/office/drawing/2014/main" id="{A6F58CFB-323E-47E0-8536-54EBDCCD8D2E}"/>
+              </a:ext>
+            </a:extLst>
+          </p:cNvPr>
+          <p:cNvSpPr>
+            <a:spLocks xmlns:a="http://schemas.openxmlformats.org/drawingml/2006/main" noGrp="1"/>
+          </p:cNvSpPr>
+          <p:nvPr/>
+        </p:nvSpPr>
+        <p:spPr>
+          <a:xfrm xmlns:a="http://schemas.openxmlformats.org/drawingml/2006/main">
+            <a:off x="4572000" y="6199632"/>
+            <a:ext cx="4023360" cy="219456"/>
+          </a:xfrm>
+          <a:prstGeom xmlns:a="http://schemas.openxmlformats.org/drawingml/2006/main" prst="rect">
+            <a:avLst/>
+          </a:prstGeom>
+          <a:noFill xmlns:a="http://schemas.openxmlformats.org/drawingml/2006/main"/>
+        </p:spPr>
+        <p:txBody>
+          <a:bodyPr xmlns:a="http://schemas.openxmlformats.org/drawingml/2006/main" wrap="square" lIns="0" tIns="0" rIns="0" bIns="0" anchor="ctr"/>
+          <a:lstStyle xmlns:a="http://schemas.openxmlformats.org/drawingml/2006/main"/>
+          <a:p xmlns:a="http://schemas.openxmlformats.org/drawingml/2006/main">
+            <a:pPr marL="0" indent="0" algn="r">
+              <a:buNone/>
+            </a:pPr>
+            <a:r>
+              <a:rPr sz="750">
+                <a:solidFill>
+                  <a:srgbClr val="7F7F7F"/>
+                </a:solidFill>
+                <a:latin typeface="Arial"/>
+                <a:ea typeface="Arial"/>
+                <a:cs typeface="Arial"/>
+              </a:rPr>
+              <a:t>Source: cascade_radar_axes_origin.csv (within-pool favorable percentiles; air axes excluded)</a:t>
+            </a:r>
+            <a:endParaRPr sz="750"/>
+          </a:p>
+        </p:txBody>
+      </p:sp>
+    </p:spTree>
+    <p:extLst>
+      <p:ext uri="{BB962C8B-B14F-4D97-AF65-F5344CB8AC3E}">
+        <p14:creationId xmlns:p14="http://schemas.microsoft.com/office/powerpoint/2010/main" val="975382810"/>
       </p:ext>
     </p:extLst>
   </p:cSld>

</xml_diff>